<commit_message>
Add conversational speaker notes to the research update deck
One note per slide (2-4 sentences, oral delivery style) in the PowerPoint
Notes pane - explains motivation/takeaway/transitions rather than
restating the on-slide bullets, so the deck can be presented from
Presenter View without reading slides aloud.

Co-Authored-By: Claude Sonnet 5 <noreply@anthropic.com>
</commit_message>
<xml_diff>
--- a/Vegetation_Forecasting_Research_Update.pptx
+++ b/Vegetation_Forecasting_Research_Update.pptx
@@ -119,6 +119,1406 @@
     </a:lvl9pPr>
   </p:defaultTextStyle>
 </p:presentation>
+</file>
+
+<file path=ppt/notesMasters/notesMaster1.xml><?xml version="1.0" encoding="utf-8"?>
+<p:notesMaster xmlns:a="http://schemas.openxmlformats.org/drawingml/2006/main" xmlns:p="http://schemas.openxmlformats.org/presentationml/2006/main" xmlns:r="http://schemas.openxmlformats.org/officeDocument/2006/relationships">
+  <p:cSld>
+    <p:bg>
+      <p:bgRef idx="1001">
+        <a:schemeClr val="bg1"/>
+      </p:bgRef>
+    </p:bg>
+    <p:spTree>
+      <p:nvGrpSpPr>
+        <p:cNvPr id="1" name=""/>
+        <p:cNvGrpSpPr/>
+        <p:nvPr/>
+      </p:nvGrpSpPr>
+      <p:grpSpPr>
+        <a:xfrm>
+          <a:off x="0" y="0"/>
+          <a:ext cx="0" cy="0"/>
+          <a:chOff x="0" y="0"/>
+          <a:chExt cx="0" cy="0"/>
+        </a:xfrm>
+      </p:grpSpPr>
+      <p:sp>
+        <p:nvSpPr>
+          <p:cNvPr id="2" name="Header Placeholder 1"/>
+          <p:cNvSpPr>
+            <a:spLocks noGrp="1"/>
+          </p:cNvSpPr>
+          <p:nvPr>
+            <p:ph type="hdr" sz="quarter"/>
+          </p:nvPr>
+        </p:nvSpPr>
+        <p:spPr>
+          <a:xfrm>
+            <a:off x="0" y="0"/>
+            <a:ext cx="2971800" cy="457200"/>
+          </a:xfrm>
+          <a:prstGeom prst="rect">
+            <a:avLst/>
+          </a:prstGeom>
+        </p:spPr>
+        <p:txBody>
+          <a:bodyPr vert="horz" lIns="91440" tIns="45720" rIns="91440" bIns="45720" rtlCol="0"/>
+          <a:lstStyle>
+            <a:lvl1pPr algn="l">
+              <a:defRPr sz="1200"/>
+            </a:lvl1pPr>
+          </a:lstStyle>
+          <a:p>
+            <a:endParaRPr lang="en-US"/>
+          </a:p>
+        </p:txBody>
+      </p:sp>
+      <p:sp>
+        <p:nvSpPr>
+          <p:cNvPr id="3" name="Date Placeholder 2"/>
+          <p:cNvSpPr>
+            <a:spLocks noGrp="1"/>
+          </p:cNvSpPr>
+          <p:nvPr>
+            <p:ph type="dt" idx="1"/>
+          </p:nvPr>
+        </p:nvSpPr>
+        <p:spPr>
+          <a:xfrm>
+            <a:off x="3884613" y="0"/>
+            <a:ext cx="2971800" cy="457200"/>
+          </a:xfrm>
+          <a:prstGeom prst="rect">
+            <a:avLst/>
+          </a:prstGeom>
+        </p:spPr>
+        <p:txBody>
+          <a:bodyPr vert="horz" lIns="91440" tIns="45720" rIns="91440" bIns="45720" rtlCol="0"/>
+          <a:lstStyle>
+            <a:lvl1pPr algn="r">
+              <a:defRPr sz="1200"/>
+            </a:lvl1pPr>
+          </a:lstStyle>
+          <a:p>
+            <a:fld id="{0F89C1C7-3DCD-1040-A9CF-14679D8B5DDD}" type="datetimeFigureOut">
+              <a:rPr lang="en-US" smtClean="0"/>
+              <a:t>10/17/16</a:t>
+            </a:fld>
+            <a:endParaRPr lang="en-US"/>
+          </a:p>
+        </p:txBody>
+      </p:sp>
+      <p:sp>
+        <p:nvSpPr>
+          <p:cNvPr id="4" name="Slide Image Placeholder 3"/>
+          <p:cNvSpPr>
+            <a:spLocks noGrp="1" noRot="1" noChangeAspect="1"/>
+          </p:cNvSpPr>
+          <p:nvPr>
+            <p:ph type="sldImg" idx="2"/>
+          </p:nvPr>
+        </p:nvSpPr>
+        <p:spPr>
+          <a:xfrm>
+            <a:off x="1143000" y="685800"/>
+            <a:ext cx="4572000" cy="3429000"/>
+          </a:xfrm>
+          <a:prstGeom prst="rect">
+            <a:avLst/>
+          </a:prstGeom>
+          <a:noFill/>
+          <a:ln w="12700">
+            <a:solidFill>
+              <a:prstClr val="black"/>
+            </a:solidFill>
+          </a:ln>
+        </p:spPr>
+        <p:txBody>
+          <a:bodyPr vert="horz" lIns="91440" tIns="45720" rIns="91440" bIns="45720" rtlCol="0" anchor="ctr"/>
+          <a:lstStyle/>
+          <a:p>
+            <a:endParaRPr lang="en-US"/>
+          </a:p>
+        </p:txBody>
+      </p:sp>
+      <p:sp>
+        <p:nvSpPr>
+          <p:cNvPr id="5" name="Notes Placeholder 4"/>
+          <p:cNvSpPr>
+            <a:spLocks noGrp="1"/>
+          </p:cNvSpPr>
+          <p:nvPr>
+            <p:ph type="body" sz="quarter" idx="3"/>
+          </p:nvPr>
+        </p:nvSpPr>
+        <p:spPr>
+          <a:xfrm>
+            <a:off x="685800" y="4343400"/>
+            <a:ext cx="5486400" cy="4114800"/>
+          </a:xfrm>
+          <a:prstGeom prst="rect">
+            <a:avLst/>
+          </a:prstGeom>
+        </p:spPr>
+        <p:txBody>
+          <a:bodyPr vert="horz" lIns="91440" tIns="45720" rIns="91440" bIns="45720" rtlCol="0"/>
+          <a:lstStyle/>
+          <a:p>
+            <a:pPr lvl="0"/>
+            <a:r>
+              <a:rPr lang="en-US" smtClean="0"/>
+              <a:t>Click to edit Master text styles</a:t>
+            </a:r>
+          </a:p>
+          <a:p>
+            <a:pPr lvl="1"/>
+            <a:r>
+              <a:rPr lang="en-US" smtClean="0"/>
+              <a:t>Second level</a:t>
+            </a:r>
+          </a:p>
+          <a:p>
+            <a:pPr lvl="2"/>
+            <a:r>
+              <a:rPr lang="en-US" smtClean="0"/>
+              <a:t>Third level</a:t>
+            </a:r>
+          </a:p>
+          <a:p>
+            <a:pPr lvl="3"/>
+            <a:r>
+              <a:rPr lang="en-US" smtClean="0"/>
+              <a:t>Fourth level</a:t>
+            </a:r>
+          </a:p>
+          <a:p>
+            <a:pPr lvl="4"/>
+            <a:r>
+              <a:rPr lang="en-US" smtClean="0"/>
+              <a:t>Fifth level</a:t>
+            </a:r>
+            <a:endParaRPr lang="en-US"/>
+          </a:p>
+        </p:txBody>
+      </p:sp>
+      <p:sp>
+        <p:nvSpPr>
+          <p:cNvPr id="6" name="Footer Placeholder 5"/>
+          <p:cNvSpPr>
+            <a:spLocks noGrp="1"/>
+          </p:cNvSpPr>
+          <p:nvPr>
+            <p:ph type="ftr" sz="quarter" idx="4"/>
+          </p:nvPr>
+        </p:nvSpPr>
+        <p:spPr>
+          <a:xfrm>
+            <a:off x="0" y="8685213"/>
+            <a:ext cx="2971800" cy="457200"/>
+          </a:xfrm>
+          <a:prstGeom prst="rect">
+            <a:avLst/>
+          </a:prstGeom>
+        </p:spPr>
+        <p:txBody>
+          <a:bodyPr vert="horz" lIns="91440" tIns="45720" rIns="91440" bIns="45720" rtlCol="0" anchor="b"/>
+          <a:lstStyle>
+            <a:lvl1pPr algn="l">
+              <a:defRPr sz="1200"/>
+            </a:lvl1pPr>
+          </a:lstStyle>
+          <a:p>
+            <a:endParaRPr lang="en-US"/>
+          </a:p>
+        </p:txBody>
+      </p:sp>
+      <p:sp>
+        <p:nvSpPr>
+          <p:cNvPr id="7" name="Slide Number Placeholder 6"/>
+          <p:cNvSpPr>
+            <a:spLocks noGrp="1"/>
+          </p:cNvSpPr>
+          <p:nvPr>
+            <p:ph type="sldNum" sz="quarter" idx="5"/>
+          </p:nvPr>
+        </p:nvSpPr>
+        <p:spPr>
+          <a:xfrm>
+            <a:off x="3884613" y="8685213"/>
+            <a:ext cx="2971800" cy="457200"/>
+          </a:xfrm>
+          <a:prstGeom prst="rect">
+            <a:avLst/>
+          </a:prstGeom>
+        </p:spPr>
+        <p:txBody>
+          <a:bodyPr vert="horz" lIns="91440" tIns="45720" rIns="91440" bIns="45720" rtlCol="0" anchor="b"/>
+          <a:lstStyle>
+            <a:lvl1pPr algn="r">
+              <a:defRPr sz="1200"/>
+            </a:lvl1pPr>
+          </a:lstStyle>
+          <a:p>
+            <a:fld id="{BB5E49A5-4136-284D-997B-48E1D791AD67}" type="slidenum">
+              <a:rPr lang="en-US" smtClean="0"/>
+              <a:t>‹#›</a:t>
+            </a:fld>
+            <a:endParaRPr lang="en-US"/>
+          </a:p>
+        </p:txBody>
+      </p:sp>
+    </p:spTree>
+    <p:extLst>
+      <p:ext uri="{BB962C8B-B14F-4D97-AF65-F5344CB8AC3E}">
+        <p14:creationId xmlns:p14="http://schemas.microsoft.com/office/powerpoint/2010/main" val="2623252185"/>
+      </p:ext>
+    </p:extLst>
+  </p:cSld>
+  <p:clrMap bg1="lt1" tx1="dk1" bg2="lt2" tx2="dk2" accent1="accent1" accent2="accent2" accent3="accent3" accent4="accent4" accent5="accent5" accent6="accent6" hlink="hlink" folHlink="folHlink"/>
+  <p:notesStyle>
+    <a:lvl1pPr marL="0" algn="l" defTabSz="457200" rtl="0" eaLnBrk="1" latinLnBrk="0" hangingPunct="1">
+      <a:defRPr sz="1200" kern="1200">
+        <a:solidFill>
+          <a:schemeClr val="tx1"/>
+        </a:solidFill>
+        <a:latin typeface="+mn-lt"/>
+        <a:ea typeface="+mn-ea"/>
+        <a:cs typeface="+mn-cs"/>
+      </a:defRPr>
+    </a:lvl1pPr>
+    <a:lvl2pPr marL="457200" algn="l" defTabSz="457200" rtl="0" eaLnBrk="1" latinLnBrk="0" hangingPunct="1">
+      <a:defRPr sz="1200" kern="1200">
+        <a:solidFill>
+          <a:schemeClr val="tx1"/>
+        </a:solidFill>
+        <a:latin typeface="+mn-lt"/>
+        <a:ea typeface="+mn-ea"/>
+        <a:cs typeface="+mn-cs"/>
+      </a:defRPr>
+    </a:lvl2pPr>
+    <a:lvl3pPr marL="914400" algn="l" defTabSz="457200" rtl="0" eaLnBrk="1" latinLnBrk="0" hangingPunct="1">
+      <a:defRPr sz="1200" kern="1200">
+        <a:solidFill>
+          <a:schemeClr val="tx1"/>
+        </a:solidFill>
+        <a:latin typeface="+mn-lt"/>
+        <a:ea typeface="+mn-ea"/>
+        <a:cs typeface="+mn-cs"/>
+      </a:defRPr>
+    </a:lvl3pPr>
+    <a:lvl4pPr marL="1371600" algn="l" defTabSz="457200" rtl="0" eaLnBrk="1" latinLnBrk="0" hangingPunct="1">
+      <a:defRPr sz="1200" kern="1200">
+        <a:solidFill>
+          <a:schemeClr val="tx1"/>
+        </a:solidFill>
+        <a:latin typeface="+mn-lt"/>
+        <a:ea typeface="+mn-ea"/>
+        <a:cs typeface="+mn-cs"/>
+      </a:defRPr>
+    </a:lvl4pPr>
+    <a:lvl5pPr marL="1828800" algn="l" defTabSz="457200" rtl="0" eaLnBrk="1" latinLnBrk="0" hangingPunct="1">
+      <a:defRPr sz="1200" kern="1200">
+        <a:solidFill>
+          <a:schemeClr val="tx1"/>
+        </a:solidFill>
+        <a:latin typeface="+mn-lt"/>
+        <a:ea typeface="+mn-ea"/>
+        <a:cs typeface="+mn-cs"/>
+      </a:defRPr>
+    </a:lvl5pPr>
+    <a:lvl6pPr marL="2286000" algn="l" defTabSz="457200" rtl="0" eaLnBrk="1" latinLnBrk="0" hangingPunct="1">
+      <a:defRPr sz="1200" kern="1200">
+        <a:solidFill>
+          <a:schemeClr val="tx1"/>
+        </a:solidFill>
+        <a:latin typeface="+mn-lt"/>
+        <a:ea typeface="+mn-ea"/>
+        <a:cs typeface="+mn-cs"/>
+      </a:defRPr>
+    </a:lvl6pPr>
+    <a:lvl7pPr marL="2743200" algn="l" defTabSz="457200" rtl="0" eaLnBrk="1" latinLnBrk="0" hangingPunct="1">
+      <a:defRPr sz="1200" kern="1200">
+        <a:solidFill>
+          <a:schemeClr val="tx1"/>
+        </a:solidFill>
+        <a:latin typeface="+mn-lt"/>
+        <a:ea typeface="+mn-ea"/>
+        <a:cs typeface="+mn-cs"/>
+      </a:defRPr>
+    </a:lvl7pPr>
+    <a:lvl8pPr marL="3200400" algn="l" defTabSz="457200" rtl="0" eaLnBrk="1" latinLnBrk="0" hangingPunct="1">
+      <a:defRPr sz="1200" kern="1200">
+        <a:solidFill>
+          <a:schemeClr val="tx1"/>
+        </a:solidFill>
+        <a:latin typeface="+mn-lt"/>
+        <a:ea typeface="+mn-ea"/>
+        <a:cs typeface="+mn-cs"/>
+      </a:defRPr>
+    </a:lvl8pPr>
+    <a:lvl9pPr marL="3657600" algn="l" defTabSz="457200" rtl="0" eaLnBrk="1" latinLnBrk="0" hangingPunct="1">
+      <a:defRPr sz="1200" kern="1200">
+        <a:solidFill>
+          <a:schemeClr val="tx1"/>
+        </a:solidFill>
+        <a:latin typeface="+mn-lt"/>
+        <a:ea typeface="+mn-ea"/>
+        <a:cs typeface="+mn-cs"/>
+      </a:defRPr>
+    </a:lvl9pPr>
+  </p:notesStyle>
+</p:notesMaster>
+</file>
+
+<file path=ppt/notesSlides/notesSlide1.xml><?xml version="1.0" encoding="utf-8"?>
+<p:notes xmlns:a="http://schemas.openxmlformats.org/drawingml/2006/main" xmlns:p="http://schemas.openxmlformats.org/presentationml/2006/main" xmlns:r="http://schemas.openxmlformats.org/officeDocument/2006/relationships">
+  <p:cSld>
+    <p:spTree>
+      <p:nvGrpSpPr>
+        <p:cNvPr id="1" name=""/>
+        <p:cNvGrpSpPr/>
+        <p:nvPr/>
+      </p:nvGrpSpPr>
+      <p:grpSpPr>
+        <a:xfrm>
+          <a:off x="0" y="0"/>
+          <a:ext cx="0" cy="0"/>
+          <a:chOff x="0" y="0"/>
+          <a:chExt cx="0" cy="0"/>
+        </a:xfrm>
+      </p:grpSpPr>
+      <p:sp>
+        <p:nvSpPr>
+          <p:cNvPr id="2" name="Slide Image Placeholder 1"/>
+          <p:cNvSpPr>
+            <a:spLocks noGrp="1"/>
+          </p:cNvSpPr>
+          <p:nvPr>
+            <p:ph type="sldImg" idx="2"/>
+          </p:nvPr>
+        </p:nvSpPr>
+        <p:spPr/>
+      </p:sp>
+      <p:sp>
+        <p:nvSpPr>
+          <p:cNvPr id="3" name="Notes Placeholder 2"/>
+          <p:cNvSpPr>
+            <a:spLocks noGrp="1"/>
+          </p:cNvSpPr>
+          <p:nvPr>
+            <p:ph type="body" idx="3" sz="quarter"/>
+          </p:nvPr>
+        </p:nvSpPr>
+        <p:spPr/>
+        <p:txBody>
+          <a:bodyPr/>
+          <a:lstStyle/>
+          <a:p>
+            <a:r>
+              <a:t>Thanks everyone — today I want to walk through three follow-up studies I ran this week on top of our AELSTM and Chronos-2 vegetation forecasting work. The short version: we now have a much more robust evaluation, a clearer picture of which climate variables actually matter, and a fix for something that was quietly hurting our fine-tuning results. Let's dive in.</a:t>
+            </a:r>
+          </a:p>
+        </p:txBody>
+      </p:sp>
+      <p:sp>
+        <p:nvSpPr>
+          <p:cNvPr id="4" name="Slide Number Placeholder 3"/>
+          <p:cNvSpPr>
+            <a:spLocks noGrp="1"/>
+          </p:cNvSpPr>
+          <p:nvPr>
+            <p:ph type="sldNum" idx="5" sz="quarter"/>
+          </p:nvPr>
+        </p:nvSpPr>
+        <p:spPr/>
+      </p:sp>
+    </p:spTree>
+  </p:cSld>
+  <p:clrMapOvr>
+    <a:masterClrMapping/>
+  </p:clrMapOvr>
+</p:notes>
+</file>
+
+<file path=ppt/notesSlides/notesSlide10.xml><?xml version="1.0" encoding="utf-8"?>
+<p:notes xmlns:a="http://schemas.openxmlformats.org/drawingml/2006/main" xmlns:p="http://schemas.openxmlformats.org/presentationml/2006/main" xmlns:r="http://schemas.openxmlformats.org/officeDocument/2006/relationships">
+  <p:cSld>
+    <p:spTree>
+      <p:nvGrpSpPr>
+        <p:cNvPr id="1" name=""/>
+        <p:cNvGrpSpPr/>
+        <p:nvPr/>
+      </p:nvGrpSpPr>
+      <p:grpSpPr>
+        <a:xfrm>
+          <a:off x="0" y="0"/>
+          <a:ext cx="0" cy="0"/>
+          <a:chOff x="0" y="0"/>
+          <a:chExt cx="0" cy="0"/>
+        </a:xfrm>
+      </p:grpSpPr>
+      <p:sp>
+        <p:nvSpPr>
+          <p:cNvPr id="2" name="Slide Image Placeholder 1"/>
+          <p:cNvSpPr>
+            <a:spLocks noGrp="1"/>
+          </p:cNvSpPr>
+          <p:nvPr>
+            <p:ph type="sldImg" idx="2"/>
+          </p:nvPr>
+        </p:nvSpPr>
+        <p:spPr/>
+      </p:sp>
+      <p:sp>
+        <p:nvSpPr>
+          <p:cNvPr id="3" name="Notes Placeholder 2"/>
+          <p:cNvSpPr>
+            <a:spLocks noGrp="1"/>
+          </p:cNvSpPr>
+          <p:nvPr>
+            <p:ph type="body" idx="3" sz="quarter"/>
+          </p:nvPr>
+        </p:nvSpPr>
+        <p:spPr/>
+        <p:txBody>
+          <a:bodyPr/>
+          <a:lstStyle/>
+          <a:p>
+            <a:r>
+              <a:t>This heatmap is really the core result — each cell shows how much a model's R² changes when we remove one predictor, broken out by pixel. The big takeaway is that this is messy in a good way — removing the same variable can help one model and hurt another at the exact same pixel. So there's no single universal ranking of what matters — it depends on both the model and the location.</a:t>
+            </a:r>
+          </a:p>
+        </p:txBody>
+      </p:sp>
+      <p:sp>
+        <p:nvSpPr>
+          <p:cNvPr id="4" name="Slide Number Placeholder 3"/>
+          <p:cNvSpPr>
+            <a:spLocks noGrp="1"/>
+          </p:cNvSpPr>
+          <p:nvPr>
+            <p:ph type="sldNum" idx="5" sz="quarter"/>
+          </p:nvPr>
+        </p:nvSpPr>
+        <p:spPr/>
+      </p:sp>
+    </p:spTree>
+  </p:cSld>
+  <p:clrMapOvr>
+    <a:masterClrMapping/>
+  </p:clrMapOvr>
+</p:notes>
+</file>
+
+<file path=ppt/notesSlides/notesSlide11.xml><?xml version="1.0" encoding="utf-8"?>
+<p:notes xmlns:a="http://schemas.openxmlformats.org/drawingml/2006/main" xmlns:p="http://schemas.openxmlformats.org/presentationml/2006/main" xmlns:r="http://schemas.openxmlformats.org/officeDocument/2006/relationships">
+  <p:cSld>
+    <p:spTree>
+      <p:nvGrpSpPr>
+        <p:cNvPr id="1" name=""/>
+        <p:cNvGrpSpPr/>
+        <p:nvPr/>
+      </p:nvGrpSpPr>
+      <p:grpSpPr>
+        <a:xfrm>
+          <a:off x="0" y="0"/>
+          <a:ext cx="0" cy="0"/>
+          <a:chOff x="0" y="0"/>
+          <a:chExt cx="0" cy="0"/>
+        </a:xfrm>
+      </p:grpSpPr>
+      <p:sp>
+        <p:nvSpPr>
+          <p:cNvPr id="2" name="Slide Image Placeholder 1"/>
+          <p:cNvSpPr>
+            <a:spLocks noGrp="1"/>
+          </p:cNvSpPr>
+          <p:nvPr>
+            <p:ph type="sldImg" idx="2"/>
+          </p:nvPr>
+        </p:nvSpPr>
+        <p:spPr/>
+      </p:sp>
+      <p:sp>
+        <p:nvSpPr>
+          <p:cNvPr id="3" name="Notes Placeholder 2"/>
+          <p:cNvSpPr>
+            <a:spLocks noGrp="1"/>
+          </p:cNvSpPr>
+          <p:nvPr>
+            <p:ph type="body" idx="3" sz="quarter"/>
+          </p:nvPr>
+        </p:nvSpPr>
+        <p:spPr/>
+        <p:txBody>
+          <a:bodyPr/>
+          <a:lstStyle/>
+          <a:p>
+            <a:r>
+              <a:t>If I had to boil it down to one number, solar radiation is the one variable that helps everywhere, consistently — the closest thing we have to a universally important predictor. On the other end, wind speed and precipitation turned out to be somewhat redundant — this chart shows that dropping just those two actually improved average performance across all three pixels. So there's a real case for simplifying our feature set.</a:t>
+            </a:r>
+          </a:p>
+        </p:txBody>
+      </p:sp>
+      <p:sp>
+        <p:nvSpPr>
+          <p:cNvPr id="4" name="Slide Number Placeholder 3"/>
+          <p:cNvSpPr>
+            <a:spLocks noGrp="1"/>
+          </p:cNvSpPr>
+          <p:nvPr>
+            <p:ph type="sldNum" idx="5" sz="quarter"/>
+          </p:nvPr>
+        </p:nvSpPr>
+        <p:spPr/>
+      </p:sp>
+    </p:spTree>
+  </p:cSld>
+  <p:clrMapOvr>
+    <a:masterClrMapping/>
+  </p:clrMapOvr>
+</p:notes>
+</file>
+
+<file path=ppt/notesSlides/notesSlide12.xml><?xml version="1.0" encoding="utf-8"?>
+<p:notes xmlns:a="http://schemas.openxmlformats.org/drawingml/2006/main" xmlns:p="http://schemas.openxmlformats.org/presentationml/2006/main" xmlns:r="http://schemas.openxmlformats.org/officeDocument/2006/relationships">
+  <p:cSld>
+    <p:spTree>
+      <p:nvGrpSpPr>
+        <p:cNvPr id="1" name=""/>
+        <p:cNvGrpSpPr/>
+        <p:nvPr/>
+      </p:nvGrpSpPr>
+      <p:grpSpPr>
+        <a:xfrm>
+          <a:off x="0" y="0"/>
+          <a:ext cx="0" cy="0"/>
+          <a:chOff x="0" y="0"/>
+          <a:chExt cx="0" cy="0"/>
+        </a:xfrm>
+      </p:grpSpPr>
+      <p:sp>
+        <p:nvSpPr>
+          <p:cNvPr id="2" name="Slide Image Placeholder 1"/>
+          <p:cNvSpPr>
+            <a:spLocks noGrp="1"/>
+          </p:cNvSpPr>
+          <p:nvPr>
+            <p:ph type="sldImg" idx="2"/>
+          </p:nvPr>
+        </p:nvSpPr>
+        <p:spPr/>
+      </p:sp>
+      <p:sp>
+        <p:nvSpPr>
+          <p:cNvPr id="3" name="Notes Placeholder 2"/>
+          <p:cNvSpPr>
+            <a:spLocks noGrp="1"/>
+          </p:cNvSpPr>
+          <p:nvPr>
+            <p:ph type="body" idx="3" sz="quarter"/>
+          </p:nvPr>
+        </p:nvSpPr>
+        <p:spPr/>
+        <p:txBody>
+          <a:bodyPr/>
+          <a:lstStyle/>
+          <a:p>
+            <a:r>
+              <a:t>Now, the third piece — and this one's a bit of a confession. When we first tried fine-tuning Chronos-2 with LoRA, it consistently made things worse, and I wanted to understand why. Turns out the way we originally set it up, the model just trained for a fixed number of steps with no way to check whether it was still improving or already overfitting — it just used whatever weights it happened to end up with.</a:t>
+            </a:r>
+          </a:p>
+        </p:txBody>
+      </p:sp>
+      <p:sp>
+        <p:nvSpPr>
+          <p:cNvPr id="4" name="Slide Number Placeholder 3"/>
+          <p:cNvSpPr>
+            <a:spLocks noGrp="1"/>
+          </p:cNvSpPr>
+          <p:nvPr>
+            <p:ph type="sldNum" idx="5" sz="quarter"/>
+          </p:nvPr>
+        </p:nvSpPr>
+        <p:spPr/>
+      </p:sp>
+    </p:spTree>
+  </p:cSld>
+  <p:clrMapOvr>
+    <a:masterClrMapping/>
+  </p:clrMapOvr>
+</p:notes>
+</file>
+
+<file path=ppt/notesSlides/notesSlide13.xml><?xml version="1.0" encoding="utf-8"?>
+<p:notes xmlns:a="http://schemas.openxmlformats.org/drawingml/2006/main" xmlns:p="http://schemas.openxmlformats.org/presentationml/2006/main" xmlns:r="http://schemas.openxmlformats.org/officeDocument/2006/relationships">
+  <p:cSld>
+    <p:spTree>
+      <p:nvGrpSpPr>
+        <p:cNvPr id="1" name=""/>
+        <p:cNvGrpSpPr/>
+        <p:nvPr/>
+      </p:nvGrpSpPr>
+      <p:grpSpPr>
+        <a:xfrm>
+          <a:off x="0" y="0"/>
+          <a:ext cx="0" cy="0"/>
+          <a:chOff x="0" y="0"/>
+          <a:chExt cx="0" cy="0"/>
+        </a:xfrm>
+      </p:grpSpPr>
+      <p:sp>
+        <p:nvSpPr>
+          <p:cNvPr id="2" name="Slide Image Placeholder 1"/>
+          <p:cNvSpPr>
+            <a:spLocks noGrp="1"/>
+          </p:cNvSpPr>
+          <p:nvPr>
+            <p:ph type="sldImg" idx="2"/>
+          </p:nvPr>
+        </p:nvSpPr>
+        <p:spPr/>
+      </p:sp>
+      <p:sp>
+        <p:nvSpPr>
+          <p:cNvPr id="3" name="Notes Placeholder 2"/>
+          <p:cNvSpPr>
+            <a:spLocks noGrp="1"/>
+          </p:cNvSpPr>
+          <p:nvPr>
+            <p:ph type="body" idx="3" sz="quarter"/>
+          </p:nvPr>
+        </p:nvSpPr>
+        <p:spPr/>
+        <p:txBody>
+          <a:bodyPr/>
+          <a:lstStyle/>
+          <a:p>
+            <a:r>
+              <a:t>So I fixed that by holding out some of the pre-2022 data as a proper validation set, and letting the model pick its own best checkpoint based on validation performance instead of stopping at a fixed number. These curves tell a great story — at the grassland pixel, the model overfits almost immediately, right at the first checkpoint, while at the other two pixels you can actually see a clear sweet spot in the middle before it starts overfitting.</a:t>
+            </a:r>
+          </a:p>
+        </p:txBody>
+      </p:sp>
+      <p:sp>
+        <p:nvSpPr>
+          <p:cNvPr id="4" name="Slide Number Placeholder 3"/>
+          <p:cNvSpPr>
+            <a:spLocks noGrp="1"/>
+          </p:cNvSpPr>
+          <p:nvPr>
+            <p:ph type="sldNum" idx="5" sz="quarter"/>
+          </p:nvPr>
+        </p:nvSpPr>
+        <p:spPr/>
+      </p:sp>
+    </p:spTree>
+  </p:cSld>
+  <p:clrMapOvr>
+    <a:masterClrMapping/>
+  </p:clrMapOvr>
+</p:notes>
+</file>
+
+<file path=ppt/notesSlides/notesSlide14.xml><?xml version="1.0" encoding="utf-8"?>
+<p:notes xmlns:a="http://schemas.openxmlformats.org/drawingml/2006/main" xmlns:p="http://schemas.openxmlformats.org/presentationml/2006/main" xmlns:r="http://schemas.openxmlformats.org/officeDocument/2006/relationships">
+  <p:cSld>
+    <p:spTree>
+      <p:nvGrpSpPr>
+        <p:cNvPr id="1" name=""/>
+        <p:cNvGrpSpPr/>
+        <p:nvPr/>
+      </p:nvGrpSpPr>
+      <p:grpSpPr>
+        <a:xfrm>
+          <a:off x="0" y="0"/>
+          <a:ext cx="0" cy="0"/>
+          <a:chOff x="0" y="0"/>
+          <a:chExt cx="0" cy="0"/>
+        </a:xfrm>
+      </p:grpSpPr>
+      <p:sp>
+        <p:nvSpPr>
+          <p:cNvPr id="2" name="Slide Image Placeholder 1"/>
+          <p:cNvSpPr>
+            <a:spLocks noGrp="1"/>
+          </p:cNvSpPr>
+          <p:nvPr>
+            <p:ph type="sldImg" idx="2"/>
+          </p:nvPr>
+        </p:nvSpPr>
+        <p:spPr/>
+      </p:sp>
+      <p:sp>
+        <p:nvSpPr>
+          <p:cNvPr id="3" name="Notes Placeholder 2"/>
+          <p:cNvSpPr>
+            <a:spLocks noGrp="1"/>
+          </p:cNvSpPr>
+          <p:nvPr>
+            <p:ph type="body" idx="3" sz="quarter"/>
+          </p:nvPr>
+        </p:nvSpPr>
+        <p:spPr/>
+        <p:txBody>
+          <a:bodyPr/>
+          <a:lstStyle/>
+          <a:p>
+            <a:r>
+              <a:t>So does this actually fix things? Mostly, yes. Look at the gap to zero-shot before and after — at the grassland and evergreen pixels, the original fine-tuning was way behind zero-shot, and the improved version closes almost all of that gap. It still doesn't quite beat zero-shot outright on any pixel, but the takeaway is that most of what looked like a fundamental weakness in fine-tuning was actually just a missing safety net in how we trained it.</a:t>
+            </a:r>
+          </a:p>
+        </p:txBody>
+      </p:sp>
+      <p:sp>
+        <p:nvSpPr>
+          <p:cNvPr id="4" name="Slide Number Placeholder 3"/>
+          <p:cNvSpPr>
+            <a:spLocks noGrp="1"/>
+          </p:cNvSpPr>
+          <p:nvPr>
+            <p:ph type="sldNum" idx="5" sz="quarter"/>
+          </p:nvPr>
+        </p:nvSpPr>
+        <p:spPr/>
+      </p:sp>
+    </p:spTree>
+  </p:cSld>
+  <p:clrMapOvr>
+    <a:masterClrMapping/>
+  </p:clrMapOvr>
+</p:notes>
+</file>
+
+<file path=ppt/notesSlides/notesSlide15.xml><?xml version="1.0" encoding="utf-8"?>
+<p:notes xmlns:a="http://schemas.openxmlformats.org/drawingml/2006/main" xmlns:p="http://schemas.openxmlformats.org/presentationml/2006/main" xmlns:r="http://schemas.openxmlformats.org/officeDocument/2006/relationships">
+  <p:cSld>
+    <p:spTree>
+      <p:nvGrpSpPr>
+        <p:cNvPr id="1" name=""/>
+        <p:cNvGrpSpPr/>
+        <p:nvPr/>
+      </p:nvGrpSpPr>
+      <p:grpSpPr>
+        <a:xfrm>
+          <a:off x="0" y="0"/>
+          <a:ext cx="0" cy="0"/>
+          <a:chOff x="0" y="0"/>
+          <a:chExt cx="0" cy="0"/>
+        </a:xfrm>
+      </p:grpSpPr>
+      <p:sp>
+        <p:nvSpPr>
+          <p:cNvPr id="2" name="Slide Image Placeholder 1"/>
+          <p:cNvSpPr>
+            <a:spLocks noGrp="1"/>
+          </p:cNvSpPr>
+          <p:nvPr>
+            <p:ph type="sldImg" idx="2"/>
+          </p:nvPr>
+        </p:nvSpPr>
+        <p:spPr/>
+      </p:sp>
+      <p:sp>
+        <p:nvSpPr>
+          <p:cNvPr id="3" name="Notes Placeholder 2"/>
+          <p:cNvSpPr>
+            <a:spLocks noGrp="1"/>
+          </p:cNvSpPr>
+          <p:nvPr>
+            <p:ph type="body" idx="3" sz="quarter"/>
+          </p:nvPr>
+        </p:nvSpPr>
+        <p:spPr/>
+        <p:txBody>
+          <a:bodyPr/>
+          <a:lstStyle/>
+          <a:p>
+            <a:r>
+              <a:t>So to wrap up — three things I'd want you to remember. One, don't trust a single test year, it can hide real failure modes. Two, both model performance and predictor importance are very pixel- and model-specific, so we should be cautious about one-size-fits-all conclusions. And three, fine-tuning isn't hopeless, it just needs proper validation — though it's still not our leading approach today. Happy to take questions, or we can dig into any of these in more detail.</a:t>
+            </a:r>
+          </a:p>
+        </p:txBody>
+      </p:sp>
+      <p:sp>
+        <p:nvSpPr>
+          <p:cNvPr id="4" name="Slide Number Placeholder 3"/>
+          <p:cNvSpPr>
+            <a:spLocks noGrp="1"/>
+          </p:cNvSpPr>
+          <p:nvPr>
+            <p:ph type="sldNum" idx="5" sz="quarter"/>
+          </p:nvPr>
+        </p:nvSpPr>
+        <p:spPr/>
+      </p:sp>
+    </p:spTree>
+  </p:cSld>
+  <p:clrMapOvr>
+    <a:masterClrMapping/>
+  </p:clrMapOvr>
+</p:notes>
+</file>
+
+<file path=ppt/notesSlides/notesSlide2.xml><?xml version="1.0" encoding="utf-8"?>
+<p:notes xmlns:a="http://schemas.openxmlformats.org/drawingml/2006/main" xmlns:p="http://schemas.openxmlformats.org/presentationml/2006/main" xmlns:r="http://schemas.openxmlformats.org/officeDocument/2006/relationships">
+  <p:cSld>
+    <p:spTree>
+      <p:nvGrpSpPr>
+        <p:cNvPr id="1" name=""/>
+        <p:cNvGrpSpPr/>
+        <p:nvPr/>
+      </p:nvGrpSpPr>
+      <p:grpSpPr>
+        <a:xfrm>
+          <a:off x="0" y="0"/>
+          <a:ext cx="0" cy="0"/>
+          <a:chOff x="0" y="0"/>
+          <a:chExt cx="0" cy="0"/>
+        </a:xfrm>
+      </p:grpSpPr>
+      <p:sp>
+        <p:nvSpPr>
+          <p:cNvPr id="2" name="Slide Image Placeholder 1"/>
+          <p:cNvSpPr>
+            <a:spLocks noGrp="1"/>
+          </p:cNvSpPr>
+          <p:nvPr>
+            <p:ph type="sldImg" idx="2"/>
+          </p:nvPr>
+        </p:nvSpPr>
+        <p:spPr/>
+      </p:sp>
+      <p:sp>
+        <p:nvSpPr>
+          <p:cNvPr id="3" name="Notes Placeholder 2"/>
+          <p:cNvSpPr>
+            <a:spLocks noGrp="1"/>
+          </p:cNvSpPr>
+          <p:nvPr>
+            <p:ph type="body" idx="3" sz="quarter"/>
+          </p:nvPr>
+        </p:nvSpPr>
+        <p:spPr/>
+        <p:txBody>
+          <a:bodyPr/>
+          <a:lstStyle/>
+          <a:p>
+            <a:r>
+              <a:t>Quick reminder before we get into the new stuff — we're still working with the same three pixels representing very different vegetation types, from a sparse grassland to a dense evergreen forest, and the same set of models: eight AELSTM-family baselines plus Chronos-2. Everything I'm about to show builds directly on this same foundation, so nothing here changes the setup, just how we evaluate it.</a:t>
+            </a:r>
+          </a:p>
+        </p:txBody>
+      </p:sp>
+      <p:sp>
+        <p:nvSpPr>
+          <p:cNvPr id="4" name="Slide Number Placeholder 3"/>
+          <p:cNvSpPr>
+            <a:spLocks noGrp="1"/>
+          </p:cNvSpPr>
+          <p:nvPr>
+            <p:ph type="sldNum" idx="5" sz="quarter"/>
+          </p:nvPr>
+        </p:nvSpPr>
+        <p:spPr/>
+      </p:sp>
+    </p:spTree>
+  </p:cSld>
+  <p:clrMapOvr>
+    <a:masterClrMapping/>
+  </p:clrMapOvr>
+</p:notes>
+</file>
+
+<file path=ppt/notesSlides/notesSlide3.xml><?xml version="1.0" encoding="utf-8"?>
+<p:notes xmlns:a="http://schemas.openxmlformats.org/drawingml/2006/main" xmlns:p="http://schemas.openxmlformats.org/presentationml/2006/main" xmlns:r="http://schemas.openxmlformats.org/officeDocument/2006/relationships">
+  <p:cSld>
+    <p:spTree>
+      <p:nvGrpSpPr>
+        <p:cNvPr id="1" name=""/>
+        <p:cNvGrpSpPr/>
+        <p:nvPr/>
+      </p:nvGrpSpPr>
+      <p:grpSpPr>
+        <a:xfrm>
+          <a:off x="0" y="0"/>
+          <a:ext cx="0" cy="0"/>
+          <a:chOff x="0" y="0"/>
+          <a:chExt cx="0" cy="0"/>
+        </a:xfrm>
+      </p:grpSpPr>
+      <p:sp>
+        <p:nvSpPr>
+          <p:cNvPr id="2" name="Slide Image Placeholder 1"/>
+          <p:cNvSpPr>
+            <a:spLocks noGrp="1"/>
+          </p:cNvSpPr>
+          <p:nvPr>
+            <p:ph type="sldImg" idx="2"/>
+          </p:nvPr>
+        </p:nvSpPr>
+        <p:spPr/>
+      </p:sp>
+      <p:sp>
+        <p:nvSpPr>
+          <p:cNvPr id="3" name="Notes Placeholder 2"/>
+          <p:cNvSpPr>
+            <a:spLocks noGrp="1"/>
+          </p:cNvSpPr>
+          <p:nvPr>
+            <p:ph type="body" idx="3" sz="quarter"/>
+          </p:nvPr>
+        </p:nvSpPr>
+        <p:spPr/>
+        <p:txBody>
+          <a:bodyPr/>
+          <a:lstStyle/>
+          <a:p>
+            <a:r>
+              <a:t>So here's the problem I wanted to address first. Up to now, every result we've reported was based on training through 2021 and testing on exactly one year, 2022. That's fine as far as it goes, but it only tells us how the model did on one particular year — it doesn't tell us whether that year was typical, lucky, or unlucky. And as it turns out, 2022 was actually a pretty uneventful year at all three pixels, so we've never seen how these models handle a real anomaly.</a:t>
+            </a:r>
+          </a:p>
+        </p:txBody>
+      </p:sp>
+      <p:sp>
+        <p:nvSpPr>
+          <p:cNvPr id="4" name="Slide Number Placeholder 3"/>
+          <p:cNvSpPr>
+            <a:spLocks noGrp="1"/>
+          </p:cNvSpPr>
+          <p:nvPr>
+            <p:ph type="sldNum" idx="5" sz="quarter"/>
+          </p:nvPr>
+        </p:nvSpPr>
+        <p:spPr/>
+      </p:sp>
+    </p:spTree>
+  </p:cSld>
+  <p:clrMapOvr>
+    <a:masterClrMapping/>
+  </p:clrMapOvr>
+</p:notes>
+</file>
+
+<file path=ppt/notesSlides/notesSlide4.xml><?xml version="1.0" encoding="utf-8"?>
+<p:notes xmlns:a="http://schemas.openxmlformats.org/drawingml/2006/main" xmlns:p="http://schemas.openxmlformats.org/presentationml/2006/main" xmlns:r="http://schemas.openxmlformats.org/officeDocument/2006/relationships">
+  <p:cSld>
+    <p:spTree>
+      <p:nvGrpSpPr>
+        <p:cNvPr id="1" name=""/>
+        <p:cNvGrpSpPr/>
+        <p:nvPr/>
+      </p:nvGrpSpPr>
+      <p:grpSpPr>
+        <a:xfrm>
+          <a:off x="0" y="0"/>
+          <a:ext cx="0" cy="0"/>
+          <a:chOff x="0" y="0"/>
+          <a:chExt cx="0" cy="0"/>
+        </a:xfrm>
+      </p:grpSpPr>
+      <p:sp>
+        <p:nvSpPr>
+          <p:cNvPr id="2" name="Slide Image Placeholder 1"/>
+          <p:cNvSpPr>
+            <a:spLocks noGrp="1"/>
+          </p:cNvSpPr>
+          <p:nvPr>
+            <p:ph type="sldImg" idx="2"/>
+          </p:nvPr>
+        </p:nvSpPr>
+        <p:spPr/>
+      </p:sp>
+      <p:sp>
+        <p:nvSpPr>
+          <p:cNvPr id="3" name="Notes Placeholder 2"/>
+          <p:cNvSpPr>
+            <a:spLocks noGrp="1"/>
+          </p:cNvSpPr>
+          <p:nvPr>
+            <p:ph type="body" idx="3" sz="quarter"/>
+          </p:nvPr>
+        </p:nvSpPr>
+        <p:spPr/>
+        <p:txBody>
+          <a:bodyPr/>
+          <a:lstStyle/>
+          <a:p>
+            <a:r>
+              <a:t>So the fix is what I'm calling rolling-origin LOYO cross-validation. Instead of one fixed split, we slide a 12-year training window forward one year at a time and test on whatever year comes right after it — fold one trains on 2000 to 2011 and tests on 2012, fold two shifts forward a year, and so on through 2022. That gives us 11 independent tests instead of one, and keeping the window length fixed means we're isolating genuine year-to-year difficulty rather than just seeing an effect of more or less training data.</a:t>
+            </a:r>
+          </a:p>
+        </p:txBody>
+      </p:sp>
+      <p:sp>
+        <p:nvSpPr>
+          <p:cNvPr id="4" name="Slide Number Placeholder 3"/>
+          <p:cNvSpPr>
+            <a:spLocks noGrp="1"/>
+          </p:cNvSpPr>
+          <p:nvPr>
+            <p:ph type="sldNum" idx="5" sz="quarter"/>
+          </p:nvPr>
+        </p:nvSpPr>
+        <p:spPr/>
+      </p:sp>
+    </p:spTree>
+  </p:cSld>
+  <p:clrMapOvr>
+    <a:masterClrMapping/>
+  </p:clrMapOvr>
+</p:notes>
+</file>
+
+<file path=ppt/notesSlides/notesSlide5.xml><?xml version="1.0" encoding="utf-8"?>
+<p:notes xmlns:a="http://schemas.openxmlformats.org/drawingml/2006/main" xmlns:p="http://schemas.openxmlformats.org/presentationml/2006/main" xmlns:r="http://schemas.openxmlformats.org/officeDocument/2006/relationships">
+  <p:cSld>
+    <p:spTree>
+      <p:nvGrpSpPr>
+        <p:cNvPr id="1" name=""/>
+        <p:cNvGrpSpPr/>
+        <p:nvPr/>
+      </p:nvGrpSpPr>
+      <p:grpSpPr>
+        <a:xfrm>
+          <a:off x="0" y="0"/>
+          <a:ext cx="0" cy="0"/>
+          <a:chOff x="0" y="0"/>
+          <a:chExt cx="0" cy="0"/>
+        </a:xfrm>
+      </p:grpSpPr>
+      <p:sp>
+        <p:nvSpPr>
+          <p:cNvPr id="2" name="Slide Image Placeholder 1"/>
+          <p:cNvSpPr>
+            <a:spLocks noGrp="1"/>
+          </p:cNvSpPr>
+          <p:nvPr>
+            <p:ph type="sldImg" idx="2"/>
+          </p:nvPr>
+        </p:nvSpPr>
+        <p:spPr/>
+      </p:sp>
+      <p:sp>
+        <p:nvSpPr>
+          <p:cNvPr id="3" name="Notes Placeholder 2"/>
+          <p:cNvSpPr>
+            <a:spLocks noGrp="1"/>
+          </p:cNvSpPr>
+          <p:nvPr>
+            <p:ph type="body" idx="3" sz="quarter"/>
+          </p:nvPr>
+        </p:nvSpPr>
+        <p:spPr/>
+        <p:txBody>
+          <a:bodyPr/>
+          <a:lstStyle/>
+          <a:p>
+            <a:r>
+              <a:t>Here's what that looks like in practice. Each box is one model's spread of R² across those 11 years. At the deciduous forest pixel, every method is tightly clustered near the top — real agreement across models. But look at the grassland and evergreen pixels — much wider spread, and notice those isolated dots hanging way below every box. Those are single bad years, and they're dragging the average down hard, which is exactly why we should be looking at the median, not just the mean.</a:t>
+            </a:r>
+          </a:p>
+        </p:txBody>
+      </p:sp>
+      <p:sp>
+        <p:nvSpPr>
+          <p:cNvPr id="4" name="Slide Number Placeholder 3"/>
+          <p:cNvSpPr>
+            <a:spLocks noGrp="1"/>
+          </p:cNvSpPr>
+          <p:nvPr>
+            <p:ph type="sldNum" idx="5" sz="quarter"/>
+          </p:nvPr>
+        </p:nvSpPr>
+        <p:spPr/>
+      </p:sp>
+    </p:spTree>
+  </p:cSld>
+  <p:clrMapOvr>
+    <a:masterClrMapping/>
+  </p:clrMapOvr>
+</p:notes>
+</file>
+
+<file path=ppt/notesSlides/notesSlide6.xml><?xml version="1.0" encoding="utf-8"?>
+<p:notes xmlns:a="http://schemas.openxmlformats.org/drawingml/2006/main" xmlns:p="http://schemas.openxmlformats.org/presentationml/2006/main" xmlns:r="http://schemas.openxmlformats.org/officeDocument/2006/relationships">
+  <p:cSld>
+    <p:spTree>
+      <p:nvGrpSpPr>
+        <p:cNvPr id="1" name=""/>
+        <p:cNvGrpSpPr/>
+        <p:nvPr/>
+      </p:nvGrpSpPr>
+      <p:grpSpPr>
+        <a:xfrm>
+          <a:off x="0" y="0"/>
+          <a:ext cx="0" cy="0"/>
+          <a:chOff x="0" y="0"/>
+          <a:chExt cx="0" cy="0"/>
+        </a:xfrm>
+      </p:grpSpPr>
+      <p:sp>
+        <p:nvSpPr>
+          <p:cNvPr id="2" name="Slide Image Placeholder 1"/>
+          <p:cNvSpPr>
+            <a:spLocks noGrp="1"/>
+          </p:cNvSpPr>
+          <p:nvPr>
+            <p:ph type="sldImg" idx="2"/>
+          </p:nvPr>
+        </p:nvSpPr>
+        <p:spPr/>
+      </p:sp>
+      <p:sp>
+        <p:nvSpPr>
+          <p:cNvPr id="3" name="Notes Placeholder 2"/>
+          <p:cNvSpPr>
+            <a:spLocks noGrp="1"/>
+          </p:cNvSpPr>
+          <p:nvPr>
+            <p:ph type="body" idx="3" sz="quarter"/>
+          </p:nvPr>
+        </p:nvSpPr>
+        <p:spPr/>
+        <p:txBody>
+          <a:bodyPr/>
+          <a:lstStyle/>
+          <a:p>
+            <a:r>
+              <a:t>This chart answers a slightly different question — not how good is a model, but how consistently good is it. Green is a top-three finish, red is bottom-three. Random Forest and Chronos-2 zero-shot are the two bars on the left, and they're mostly green with very little red — just reliably solid. The fine-tuned LoRA model is the interesting one — lots of green, but also a lot of red. It's not consistently bad, it's just unpredictable, which matters later in the talk.</a:t>
+            </a:r>
+          </a:p>
+        </p:txBody>
+      </p:sp>
+      <p:sp>
+        <p:nvSpPr>
+          <p:cNvPr id="4" name="Slide Number Placeholder 3"/>
+          <p:cNvSpPr>
+            <a:spLocks noGrp="1"/>
+          </p:cNvSpPr>
+          <p:nvPr>
+            <p:ph type="sldNum" idx="5" sz="quarter"/>
+          </p:nvPr>
+        </p:nvSpPr>
+        <p:spPr/>
+      </p:sp>
+    </p:spTree>
+  </p:cSld>
+  <p:clrMapOvr>
+    <a:masterClrMapping/>
+  </p:clrMapOvr>
+</p:notes>
+</file>
+
+<file path=ppt/notesSlides/notesSlide7.xml><?xml version="1.0" encoding="utf-8"?>
+<p:notes xmlns:a="http://schemas.openxmlformats.org/drawingml/2006/main" xmlns:p="http://schemas.openxmlformats.org/presentationml/2006/main" xmlns:r="http://schemas.openxmlformats.org/officeDocument/2006/relationships">
+  <p:cSld>
+    <p:spTree>
+      <p:nvGrpSpPr>
+        <p:cNvPr id="1" name=""/>
+        <p:cNvGrpSpPr/>
+        <p:nvPr/>
+      </p:nvGrpSpPr>
+      <p:grpSpPr>
+        <a:xfrm>
+          <a:off x="0" y="0"/>
+          <a:ext cx="0" cy="0"/>
+          <a:chOff x="0" y="0"/>
+          <a:chExt cx="0" cy="0"/>
+        </a:xfrm>
+      </p:grpSpPr>
+      <p:sp>
+        <p:nvSpPr>
+          <p:cNvPr id="2" name="Slide Image Placeholder 1"/>
+          <p:cNvSpPr>
+            <a:spLocks noGrp="1"/>
+          </p:cNvSpPr>
+          <p:nvPr>
+            <p:ph type="sldImg" idx="2"/>
+          </p:nvPr>
+        </p:nvSpPr>
+        <p:spPr/>
+      </p:sp>
+      <p:sp>
+        <p:nvSpPr>
+          <p:cNvPr id="3" name="Notes Placeholder 2"/>
+          <p:cNvSpPr>
+            <a:spLocks noGrp="1"/>
+          </p:cNvSpPr>
+          <p:nvPr>
+            <p:ph type="body" idx="3" sz="quarter"/>
+          </p:nvPr>
+        </p:nvSpPr>
+        <p:spPr/>
+        <p:txBody>
+          <a:bodyPr/>
+          <a:lstStyle/>
+          <a:p>
+            <a:r>
+              <a:t>I wanted to understand what was actually happening in those worst years, so I went back to the raw satellite data. Turns out we have two completely different stories here. The evergreen forest in 2012 was a real drought — the canopy never greened up the way it normally would, and every model got fooled because none of them had seen a drought like that in training. The grassland pixel in 2018 is different — climate was totally normal that year, but the vegetation response was just erratic and noisy, which is easy to miss if you only look at one test year.</a:t>
+            </a:r>
+          </a:p>
+        </p:txBody>
+      </p:sp>
+      <p:sp>
+        <p:nvSpPr>
+          <p:cNvPr id="4" name="Slide Number Placeholder 3"/>
+          <p:cNvSpPr>
+            <a:spLocks noGrp="1"/>
+          </p:cNvSpPr>
+          <p:nvPr>
+            <p:ph type="sldNum" idx="5" sz="quarter"/>
+          </p:nvPr>
+        </p:nvSpPr>
+        <p:spPr/>
+      </p:sp>
+    </p:spTree>
+  </p:cSld>
+  <p:clrMapOvr>
+    <a:masterClrMapping/>
+  </p:clrMapOvr>
+</p:notes>
+</file>
+
+<file path=ppt/notesSlides/notesSlide8.xml><?xml version="1.0" encoding="utf-8"?>
+<p:notes xmlns:a="http://schemas.openxmlformats.org/drawingml/2006/main" xmlns:p="http://schemas.openxmlformats.org/presentationml/2006/main" xmlns:r="http://schemas.openxmlformats.org/officeDocument/2006/relationships">
+  <p:cSld>
+    <p:spTree>
+      <p:nvGrpSpPr>
+        <p:cNvPr id="1" name=""/>
+        <p:cNvGrpSpPr/>
+        <p:nvPr/>
+      </p:nvGrpSpPr>
+      <p:grpSpPr>
+        <a:xfrm>
+          <a:off x="0" y="0"/>
+          <a:ext cx="0" cy="0"/>
+          <a:chOff x="0" y="0"/>
+          <a:chExt cx="0" cy="0"/>
+        </a:xfrm>
+      </p:grpSpPr>
+      <p:sp>
+        <p:nvSpPr>
+          <p:cNvPr id="2" name="Slide Image Placeholder 1"/>
+          <p:cNvSpPr>
+            <a:spLocks noGrp="1"/>
+          </p:cNvSpPr>
+          <p:nvPr>
+            <p:ph type="sldImg" idx="2"/>
+          </p:nvPr>
+        </p:nvSpPr>
+        <p:spPr/>
+      </p:sp>
+      <p:sp>
+        <p:nvSpPr>
+          <p:cNvPr id="3" name="Notes Placeholder 2"/>
+          <p:cNvSpPr>
+            <a:spLocks noGrp="1"/>
+          </p:cNvSpPr>
+          <p:nvPr>
+            <p:ph type="body" idx="3" sz="quarter"/>
+          </p:nvPr>
+        </p:nvSpPr>
+        <p:spPr/>
+        <p:txBody>
+          <a:bodyPr/>
+          <a:lstStyle/>
+          <a:p>
+            <a:r>
+              <a:t>So stepping back — the headline here is that a single test year can hide a lot. Performance really depends on which pixel and which year you happen to look at, and the two models that came out looking most dependable across the board were Random Forest and Chronos-2 zero-shot. Worth noting though — Chronos-2's advantage shows up in normal years, not the drought year, so it's not magic robustness to anomalies, it's just solid on average.</a:t>
+            </a:r>
+          </a:p>
+        </p:txBody>
+      </p:sp>
+      <p:sp>
+        <p:nvSpPr>
+          <p:cNvPr id="4" name="Slide Number Placeholder 3"/>
+          <p:cNvSpPr>
+            <a:spLocks noGrp="1"/>
+          </p:cNvSpPr>
+          <p:nvPr>
+            <p:ph type="sldNum" idx="5" sz="quarter"/>
+          </p:nvPr>
+        </p:nvSpPr>
+        <p:spPr/>
+      </p:sp>
+    </p:spTree>
+  </p:cSld>
+  <p:clrMapOvr>
+    <a:masterClrMapping/>
+  </p:clrMapOvr>
+</p:notes>
+</file>
+
+<file path=ppt/notesSlides/notesSlide9.xml><?xml version="1.0" encoding="utf-8"?>
+<p:notes xmlns:a="http://schemas.openxmlformats.org/drawingml/2006/main" xmlns:p="http://schemas.openxmlformats.org/presentationml/2006/main" xmlns:r="http://schemas.openxmlformats.org/officeDocument/2006/relationships">
+  <p:cSld>
+    <p:spTree>
+      <p:nvGrpSpPr>
+        <p:cNvPr id="1" name=""/>
+        <p:cNvGrpSpPr/>
+        <p:nvPr/>
+      </p:nvGrpSpPr>
+      <p:grpSpPr>
+        <a:xfrm>
+          <a:off x="0" y="0"/>
+          <a:ext cx="0" cy="0"/>
+          <a:chOff x="0" y="0"/>
+          <a:chExt cx="0" cy="0"/>
+        </a:xfrm>
+      </p:grpSpPr>
+      <p:sp>
+        <p:nvSpPr>
+          <p:cNvPr id="2" name="Slide Image Placeholder 1"/>
+          <p:cNvSpPr>
+            <a:spLocks noGrp="1"/>
+          </p:cNvSpPr>
+          <p:nvPr>
+            <p:ph type="sldImg" idx="2"/>
+          </p:nvPr>
+        </p:nvSpPr>
+        <p:spPr/>
+      </p:sp>
+      <p:sp>
+        <p:nvSpPr>
+          <p:cNvPr id="3" name="Notes Placeholder 2"/>
+          <p:cNvSpPr>
+            <a:spLocks noGrp="1"/>
+          </p:cNvSpPr>
+          <p:nvPr>
+            <p:ph type="body" idx="3" sz="quarter"/>
+          </p:nvPr>
+        </p:nvSpPr>
+        <p:spPr/>
+        <p:txBody>
+          <a:bodyPr/>
+          <a:lstStyle/>
+          <a:p>
+            <a:r>
+              <a:t>Okay, switching gears — the second thing I looked at this week is which of our seven climate variables actually matter. Testing every possible combination would be 128 different subsets, which is neither practical nor interpretable, so I did this in two stages instead: first drop one variable at a time and see what happens, then, based on what that showed us, test a handful of specifically chosen combinations rather than a blind search.</a:t>
+            </a:r>
+          </a:p>
+        </p:txBody>
+      </p:sp>
+      <p:sp>
+        <p:nvSpPr>
+          <p:cNvPr id="4" name="Slide Number Placeholder 3"/>
+          <p:cNvSpPr>
+            <a:spLocks noGrp="1"/>
+          </p:cNvSpPr>
+          <p:nvPr>
+            <p:ph type="sldNum" idx="5" sz="quarter"/>
+          </p:nvPr>
+        </p:nvSpPr>
+        <p:spPr/>
+      </p:sp>
+    </p:spTree>
+  </p:cSld>
+  <p:clrMapOvr>
+    <a:masterClrMapping/>
+  </p:clrMapOvr>
+</p:notes>
 </file>
 
 <file path=ppt/slideLayouts/slideLayout1.xml><?xml version="1.0" encoding="utf-8"?>
@@ -12215,4 +13615,324 @@
   </a:objectDefaults>
   <a:extraClrSchemeLst/>
 </a:theme>
+</file>
+
+<file path=ppt/theme/theme2.xml><?xml version="1.0" encoding="utf-8"?>
+<a:theme xmlns:a="http://schemas.openxmlformats.org/drawingml/2006/main" name="Office Theme">
+  <a:themeElements>
+    <a:clrScheme name="Office">
+      <a:dk1>
+        <a:sysClr val="windowText" lastClr="000000"/>
+      </a:dk1>
+      <a:lt1>
+        <a:sysClr val="window" lastClr="FFFFFF"/>
+      </a:lt1>
+      <a:dk2>
+        <a:srgbClr val="1F497D"/>
+      </a:dk2>
+      <a:lt2>
+        <a:srgbClr val="EEECE1"/>
+      </a:lt2>
+      <a:accent1>
+        <a:srgbClr val="4F81BD"/>
+      </a:accent1>
+      <a:accent2>
+        <a:srgbClr val="C0504D"/>
+      </a:accent2>
+      <a:accent3>
+        <a:srgbClr val="9BBB59"/>
+      </a:accent3>
+      <a:accent4>
+        <a:srgbClr val="8064A2"/>
+      </a:accent4>
+      <a:accent5>
+        <a:srgbClr val="4BACC6"/>
+      </a:accent5>
+      <a:accent6>
+        <a:srgbClr val="F79646"/>
+      </a:accent6>
+      <a:hlink>
+        <a:srgbClr val="0000FF"/>
+      </a:hlink>
+      <a:folHlink>
+        <a:srgbClr val="800080"/>
+      </a:folHlink>
+    </a:clrScheme>
+    <a:fontScheme name="Office">
+      <a:majorFont>
+        <a:latin typeface="Calibri"/>
+        <a:ea typeface=""/>
+        <a:cs typeface=""/>
+        <a:font script="Jpan" typeface="ＭＳ Ｐゴシック"/>
+        <a:font script="Hang" typeface="맑은 고딕"/>
+        <a:font script="Hans" typeface="宋体"/>
+        <a:font script="Hant" typeface="新細明體"/>
+        <a:font script="Arab" typeface="Times New Roman"/>
+        <a:font script="Hebr" typeface="Times New Roman"/>
+        <a:font script="Thai" typeface="Angsana New"/>
+        <a:font script="Ethi" typeface="Nyala"/>
+        <a:font script="Beng" typeface="Vrinda"/>
+        <a:font script="Gujr" typeface="Shruti"/>
+        <a:font script="Khmr" typeface="MoolBoran"/>
+        <a:font script="Knda" typeface="Tunga"/>
+        <a:font script="Guru" typeface="Raavi"/>
+        <a:font script="Cans" typeface="Euphemia"/>
+        <a:font script="Cher" typeface="Plantagenet Cherokee"/>
+        <a:font script="Yiii" typeface="Microsoft Yi Baiti"/>
+        <a:font script="Tibt" typeface="Microsoft Himalaya"/>
+        <a:font script="Thaa" typeface="MV Boli"/>
+        <a:font script="Deva" typeface="Mangal"/>
+        <a:font script="Telu" typeface="Gautami"/>
+        <a:font script="Taml" typeface="Latha"/>
+        <a:font script="Syrc" typeface="Estrangelo Edessa"/>
+        <a:font script="Orya" typeface="Kalinga"/>
+        <a:font script="Mlym" typeface="Kartika"/>
+        <a:font script="Laoo" typeface="DokChampa"/>
+        <a:font script="Sinh" typeface="Iskoola Pota"/>
+        <a:font script="Mong" typeface="Mongolian Baiti"/>
+        <a:font script="Viet" typeface="Times New Roman"/>
+        <a:font script="Uigh" typeface="Microsoft Uighur"/>
+        <a:font script="Geor" typeface="Sylfaen"/>
+      </a:majorFont>
+      <a:minorFont>
+        <a:latin typeface="Calibri"/>
+        <a:ea typeface=""/>
+        <a:cs typeface=""/>
+        <a:font script="Jpan" typeface="ＭＳ Ｐゴシック"/>
+        <a:font script="Hang" typeface="맑은 고딕"/>
+        <a:font script="Hans" typeface="宋体"/>
+        <a:font script="Hant" typeface="新細明體"/>
+        <a:font script="Arab" typeface="Arial"/>
+        <a:font script="Hebr" typeface="Arial"/>
+        <a:font script="Thai" typeface="Cordia New"/>
+        <a:font script="Ethi" typeface="Nyala"/>
+        <a:font script="Beng" typeface="Vrinda"/>
+        <a:font script="Gujr" typeface="Shruti"/>
+        <a:font script="Khmr" typeface="DaunPenh"/>
+        <a:font script="Knda" typeface="Tunga"/>
+        <a:font script="Guru" typeface="Raavi"/>
+        <a:font script="Cans" typeface="Euphemia"/>
+        <a:font script="Cher" typeface="Plantagenet Cherokee"/>
+        <a:font script="Yiii" typeface="Microsoft Yi Baiti"/>
+        <a:font script="Tibt" typeface="Microsoft Himalaya"/>
+        <a:font script="Thaa" typeface="MV Boli"/>
+        <a:font script="Deva" typeface="Mangal"/>
+        <a:font script="Telu" typeface="Gautami"/>
+        <a:font script="Taml" typeface="Latha"/>
+        <a:font script="Syrc" typeface="Estrangelo Edessa"/>
+        <a:font script="Orya" typeface="Kalinga"/>
+        <a:font script="Mlym" typeface="Kartika"/>
+        <a:font script="Laoo" typeface="DokChampa"/>
+        <a:font script="Sinh" typeface="Iskoola Pota"/>
+        <a:font script="Mong" typeface="Mongolian Baiti"/>
+        <a:font script="Viet" typeface="Arial"/>
+        <a:font script="Uigh" typeface="Microsoft Uighur"/>
+        <a:font script="Geor" typeface="Sylfaen"/>
+      </a:minorFont>
+    </a:fontScheme>
+    <a:fmtScheme name="Office">
+      <a:fillStyleLst>
+        <a:solidFill>
+          <a:schemeClr val="phClr"/>
+        </a:solidFill>
+        <a:gradFill rotWithShape="1">
+          <a:gsLst>
+            <a:gs pos="0">
+              <a:schemeClr val="phClr">
+                <a:tint val="50000"/>
+                <a:satMod val="300000"/>
+              </a:schemeClr>
+            </a:gs>
+            <a:gs pos="35000">
+              <a:schemeClr val="phClr">
+                <a:tint val="37000"/>
+                <a:satMod val="300000"/>
+              </a:schemeClr>
+            </a:gs>
+            <a:gs pos="100000">
+              <a:schemeClr val="phClr">
+                <a:tint val="15000"/>
+                <a:satMod val="350000"/>
+              </a:schemeClr>
+            </a:gs>
+          </a:gsLst>
+          <a:lin ang="16200000" scaled="1"/>
+        </a:gradFill>
+        <a:gradFill rotWithShape="1">
+          <a:gsLst>
+            <a:gs pos="0">
+              <a:schemeClr val="phClr">
+                <a:tint val="100000"/>
+                <a:shade val="100000"/>
+                <a:satMod val="130000"/>
+              </a:schemeClr>
+            </a:gs>
+            <a:gs pos="100000">
+              <a:schemeClr val="phClr">
+                <a:tint val="50000"/>
+                <a:shade val="100000"/>
+                <a:satMod val="350000"/>
+              </a:schemeClr>
+            </a:gs>
+          </a:gsLst>
+          <a:lin ang="16200000" scaled="0"/>
+        </a:gradFill>
+      </a:fillStyleLst>
+      <a:lnStyleLst>
+        <a:ln w="9525" cap="flat" cmpd="sng" algn="ctr">
+          <a:solidFill>
+            <a:schemeClr val="phClr">
+              <a:shade val="95000"/>
+              <a:satMod val="105000"/>
+            </a:schemeClr>
+          </a:solidFill>
+          <a:prstDash val="solid"/>
+        </a:ln>
+        <a:ln w="25400" cap="flat" cmpd="sng" algn="ctr">
+          <a:solidFill>
+            <a:schemeClr val="phClr"/>
+          </a:solidFill>
+          <a:prstDash val="solid"/>
+        </a:ln>
+        <a:ln w="38100" cap="flat" cmpd="sng" algn="ctr">
+          <a:solidFill>
+            <a:schemeClr val="phClr"/>
+          </a:solidFill>
+          <a:prstDash val="solid"/>
+        </a:ln>
+      </a:lnStyleLst>
+      <a:effectStyleLst>
+        <a:effectStyle>
+          <a:effectLst>
+            <a:outerShdw blurRad="40000" dist="20000" dir="5400000" rotWithShape="0">
+              <a:srgbClr val="000000">
+                <a:alpha val="38000"/>
+              </a:srgbClr>
+            </a:outerShdw>
+          </a:effectLst>
+        </a:effectStyle>
+        <a:effectStyle>
+          <a:effectLst>
+            <a:outerShdw blurRad="40000" dist="23000" dir="5400000" rotWithShape="0">
+              <a:srgbClr val="000000">
+                <a:alpha val="35000"/>
+              </a:srgbClr>
+            </a:outerShdw>
+          </a:effectLst>
+        </a:effectStyle>
+        <a:effectStyle>
+          <a:effectLst>
+            <a:outerShdw blurRad="40000" dist="23000" dir="5400000" rotWithShape="0">
+              <a:srgbClr val="000000">
+                <a:alpha val="35000"/>
+              </a:srgbClr>
+            </a:outerShdw>
+          </a:effectLst>
+          <a:scene3d>
+            <a:camera prst="orthographicFront">
+              <a:rot lat="0" lon="0" rev="0"/>
+            </a:camera>
+            <a:lightRig rig="threePt" dir="t">
+              <a:rot lat="0" lon="0" rev="1200000"/>
+            </a:lightRig>
+          </a:scene3d>
+          <a:sp3d>
+            <a:bevelT w="63500" h="25400"/>
+          </a:sp3d>
+        </a:effectStyle>
+      </a:effectStyleLst>
+      <a:bgFillStyleLst>
+        <a:solidFill>
+          <a:schemeClr val="phClr"/>
+        </a:solidFill>
+        <a:gradFill rotWithShape="1">
+          <a:gsLst>
+            <a:gs pos="0">
+              <a:schemeClr val="phClr">
+                <a:tint val="40000"/>
+                <a:satMod val="350000"/>
+              </a:schemeClr>
+            </a:gs>
+            <a:gs pos="40000">
+              <a:schemeClr val="phClr">
+                <a:tint val="45000"/>
+                <a:shade val="99000"/>
+                <a:satMod val="350000"/>
+              </a:schemeClr>
+            </a:gs>
+            <a:gs pos="100000">
+              <a:schemeClr val="phClr">
+                <a:shade val="20000"/>
+                <a:satMod val="255000"/>
+              </a:schemeClr>
+            </a:gs>
+          </a:gsLst>
+          <a:path path="circle">
+            <a:fillToRect l="50000" t="-80000" r="50000" b="180000"/>
+          </a:path>
+        </a:gradFill>
+        <a:gradFill rotWithShape="1">
+          <a:gsLst>
+            <a:gs pos="0">
+              <a:schemeClr val="phClr">
+                <a:tint val="80000"/>
+                <a:satMod val="300000"/>
+              </a:schemeClr>
+            </a:gs>
+            <a:gs pos="100000">
+              <a:schemeClr val="phClr">
+                <a:shade val="30000"/>
+                <a:satMod val="200000"/>
+              </a:schemeClr>
+            </a:gs>
+          </a:gsLst>
+          <a:path path="circle">
+            <a:fillToRect l="50000" t="50000" r="50000" b="50000"/>
+          </a:path>
+        </a:gradFill>
+      </a:bgFillStyleLst>
+    </a:fmtScheme>
+  </a:themeElements>
+  <a:objectDefaults>
+    <a:spDef>
+      <a:spPr/>
+      <a:bodyPr/>
+      <a:lstStyle/>
+      <a:style>
+        <a:lnRef idx="1">
+          <a:schemeClr val="accent1"/>
+        </a:lnRef>
+        <a:fillRef idx="3">
+          <a:schemeClr val="accent1"/>
+        </a:fillRef>
+        <a:effectRef idx="2">
+          <a:schemeClr val="accent1"/>
+        </a:effectRef>
+        <a:fontRef idx="minor">
+          <a:schemeClr val="lt1"/>
+        </a:fontRef>
+      </a:style>
+    </a:spDef>
+    <a:lnDef>
+      <a:spPr/>
+      <a:bodyPr/>
+      <a:lstStyle/>
+      <a:style>
+        <a:lnRef idx="2">
+          <a:schemeClr val="accent1"/>
+        </a:lnRef>
+        <a:fillRef idx="0">
+          <a:schemeClr val="accent1"/>
+        </a:fillRef>
+        <a:effectRef idx="1">
+          <a:schemeClr val="accent1"/>
+        </a:effectRef>
+        <a:fontRef idx="minor">
+          <a:schemeClr val="tx1"/>
+        </a:fontRef>
+      </a:style>
+    </a:lnDef>
+  </a:objectDefaults>
+  <a:extraClrSchemeLst/>
+</a:theme>
 </file>
</xml_diff>